<commit_message>
Rename project to Bloqueia Golpe and refresh presentation
</commit_message>
<xml_diff>
--- a/public/apresentacao/apresentacao-completa.pptx
+++ b/public/apresentacao/apresentacao-completa.pptx
@@ -511,7 +511,7 @@
           <a:p/>
           <a:p>
             <a:r>
-              <a:t>“Oi, gente! Nós somos Lara e Sophia e nosso site se chama ‘Isso é golpe?’. Muitas mensagens tentam assustar as pessoas com uma cobrança urgente ou um problema que precisa ser resolvido na hora. Isso pode confundir principalmente os mais velhos. Nosso site é uma ajuda para parar, conferir os sinais e pensar antes de clicar.”</a:t>
+              <a:t>“Oi, gente! Nós somos Lara e Sophia e nosso site se chama ‘Bloqueia Golpe’. Muitas mensagens tentam assustar as pessoas com uma cobrança urgente ou um problema que precisa ser resolvido na hora. Isso pode confundir principalmente os mais velhos. Nosso site é uma ajuda para parar, conferir os sinais e pensar antes de clicar.”</a:t>
             </a:r>
           </a:p>
           <a:p/>
@@ -3854,7 +3854,7 @@
       <p:grpSpPr/>
       <p:pic>
         <p:nvPicPr>
-          <p:cNvPr id="2" name="Picture 1" descr="Nome do projeto e mensagem fictícia de exemplo."/>
+          <p:cNvPr id="2" name="Picture 1" descr="novo-slide-01.png"/>
           <p:cNvPicPr>
             <a:picLocks noChangeAspect="1"/>
           </p:cNvPicPr>
@@ -3896,7 +3896,7 @@
       <p:grpSpPr/>
       <p:pic>
         <p:nvPicPr>
-          <p:cNvPr id="2" name="Picture 1" descr="Público do site: principalmente pessoas mais velhas."/>
+          <p:cNvPr id="2" name="Picture 1" descr="novo-slide-02.png"/>
           <p:cNvPicPr>
             <a:picLocks noChangeAspect="1"/>
           </p:cNvPicPr>
@@ -3938,7 +3938,7 @@
       <p:grpSpPr/>
       <p:pic>
         <p:nvPicPr>
-          <p:cNvPr id="2" name="Picture 1" descr="Ferramentas: Codex, GitHub, Vercel, Supabase e OpenRouter."/>
+          <p:cNvPr id="2" name="Picture 1" descr="novo-slide-03.png"/>
           <p:cNvPicPr>
             <a:picLocks noChangeAspect="1"/>
           </p:cNvPicPr>
@@ -3980,7 +3980,7 @@
       <p:grpSpPr/>
       <p:pic>
         <p:nvPicPr>
-          <p:cNvPr id="2" name="Picture 1" descr="Aprendizado da dupla: paciência, com apoio da OMNI e das apostilas."/>
+          <p:cNvPr id="2" name="Picture 1" descr="novo-slide-04.png"/>
           <p:cNvPicPr>
             <a:picLocks noChangeAspect="1"/>
           </p:cNvPicPr>

</xml_diff>